<commit_message>
Update defense deck and Q&A for the messaging removal
Slide 8 replaces messaging with the review rules, slide 9 drops to five events, and slide 10 is reframed around revenue from completed bookings rather than recorded payments. The Q&A gains an honest answer on how attendance is inferred, and one explaining why messaging was removed.
</commit_message>
<xml_diff>
--- a/docs/StyleBook-Defense.pptx
+++ b/docs/StyleBook-Defense.pptx
@@ -514,7 +514,7 @@
           <a:p>
             <a:r>
               <a:rPr lang="en-US" dirty="0"/>
-              <a:t>Introduce the project in one line: StyleBook digitises salon and barbershop booking in Ghana, with a customer app and an owner dashboard sharing one backend.</a:t>
+              <a:t>StyleBook digitises salon and barbershop booking in Ghana: a customer app and an owner dashboard sharing one backend.</a:t>
             </a:r>
             <a:endParaRPr lang="en-US" dirty="0"/>
           </a:p>
@@ -602,7 +602,7 @@
           <a:p>
             <a:r>
               <a:rPr lang="en-US" dirty="0"/>
-              <a:t>If asked whether payments are real: no. StyleBook records payments and issues receipts; processing them would require Paystack or Hubtel and a settlement webhook. Say this plainly — it is a stronger answer than implying otherwise.</a:t>
+              <a:t>If asked whether payments are real: no, and say so plainly. StyleBook records money rather than moving it. Processing would need Paystack or Hubtel and a settlement webhook.</a:t>
             </a:r>
             <a:endParaRPr lang="en-US" dirty="0"/>
           </a:p>
@@ -690,7 +690,7 @@
           <a:p>
             <a:r>
               <a:rPr lang="en-US" dirty="0"/>
-              <a:t>Four concrete mechanisms, then the principle. If pushed on what you would harden: HTTPS everywhere, refresh tokens and revocation, rate limiting on auth endpoints.</a:t>
+              <a:t>Four mechanisms, then the principle. If pushed on hardening: HTTPS everywhere, refresh tokens and revocation, rate limiting on auth endpoints.</a:t>
             </a:r>
             <a:endParaRPr lang="en-US" dirty="0"/>
           </a:p>
@@ -778,7 +778,7 @@
           <a:p>
             <a:r>
               <a:rPr lang="en-US" dirty="0"/>
-              <a:t>These are real incidents from this project. Examiners respond well to specific failures with specific lessons — much better than generic 'time management was hard'.</a:t>
+              <a:t>Real incidents from this project. Specific failures with specific lessons land far better than 'time management was hard'.</a:t>
             </a:r>
             <a:endParaRPr lang="en-US" dirty="0"/>
           </a:p>
@@ -866,7 +866,7 @@
           <a:p>
             <a:r>
               <a:rPr lang="en-US" dirty="0"/>
-              <a:t>Close on the roadmap, then invite questions. The APK is installed and the backend is deployed, so anything asked can be shown.</a:t>
+              <a:t>Close on the roadmap, then invite questions. Attendance check-in is listed first because it is the honest answer to the reviews limitation.</a:t>
             </a:r>
             <a:endParaRPr lang="en-US" dirty="0"/>
           </a:p>
@@ -954,7 +954,7 @@
           <a:p>
             <a:r>
               <a:rPr lang="en-US" dirty="0"/>
-              <a:t>Three problems: customers waste time, owners can't plan, discovery is word of mouth. Emphasise that this is a local problem needing a local solution.</a:t>
+              <a:t>Three problems: customers waste time, owners can't plan, discovery is word of mouth.</a:t>
             </a:r>
             <a:endParaRPr lang="en-US" dirty="0"/>
           </a:p>
@@ -1042,7 +1042,7 @@
           <a:p>
             <a:r>
               <a:rPr lang="en-US" dirty="0"/>
-              <a:t>Two distinct journeys behind one login. Role is decided at registration and enforced by the JWT, so a customer account cannot reach owner screens.</a:t>
+              <a:t>Two journeys behind one login. Role is set at registration and carried in the JWT, so a customer account cannot reach owner screens.</a:t>
             </a:r>
             <a:endParaRPr lang="en-US" dirty="0"/>
           </a:p>
@@ -1130,7 +1130,7 @@
           <a:p>
             <a:r>
               <a:rPr lang="en-US" dirty="0"/>
-              <a:t>Walk one booking end to end. The closing line is the thesis of the whole project: the client displays, the server decides.</a:t>
+              <a:t>Walk one booking end to end. The closing line is the thesis: the client displays, the server decides.</a:t>
             </a:r>
             <a:endParaRPr lang="en-US" dirty="0"/>
           </a:p>
@@ -1218,7 +1218,7 @@
           <a:p>
             <a:r>
               <a:rPr lang="en-US" dirty="0"/>
-              <a:t>Each choice has a reason. Expo for one codebase and device APIs; Spring Boot for structure and scheduled jobs; Postgres because the data is genuinely relational; Expo Push because it removes Firebase from the server entirely.</a:t>
+              <a:t>Each choice has a reason. Expo for one codebase and device APIs; Spring Boot for structure and scheduled jobs; Postgres because the data is genuinely relational.</a:t>
             </a:r>
             <a:endParaRPr lang="en-US" dirty="0"/>
           </a:p>
@@ -1306,7 +1306,7 @@
           <a:p>
             <a:r>
               <a:rPr lang="en-US" dirty="0"/>
-              <a:t>Expect a microservices question. The answer is that the seams exist but a single deployable is correct at this scale, and extraction is possible precisely because the seams exist.</a:t>
+              <a:t>Expect a microservices question. The seams exist, but one deployable is correct at this scale — and extraction is possible precisely because the seams exist.</a:t>
             </a:r>
             <a:endParaRPr lang="en-US" dirty="0"/>
           </a:p>
@@ -1394,7 +1394,7 @@
           <a:p>
             <a:r>
               <a:rPr lang="en-US" dirty="0"/>
-              <a:t>This is the technical centrepiece. Be ready to explain the overlap condition and why it re-runs at write time — that is what defeats the double-booking race.</a:t>
+              <a:t>The technical centrepiece. Be ready to explain the overlap condition and why it re-runs at write time — that is what defeats the double-booking race.</a:t>
             </a:r>
             <a:endParaRPr lang="en-US" dirty="0"/>
           </a:p>
@@ -1482,7 +1482,7 @@
           <a:p>
             <a:r>
               <a:rPr lang="en-US" dirty="0"/>
-              <a:t>Messaging replaced what would otherwise be phone calls outside the app. Note the unique constraint and the membership check — both are server-side guarantees, not UI conveniences.</a:t>
+              <a:t>The review rules are the interesting half. Naming the attendance limitation yourself is stronger than being caught by it — examiners reward knowing where your own boundaries are.</a:t>
             </a:r>
             <a:endParaRPr lang="en-US" dirty="0"/>
           </a:p>
@@ -1570,7 +1570,7 @@
           <a:p>
             <a:r>
               <a:rPr lang="en-US" dirty="0"/>
-              <a:t>The point of this slide is decoupling: six unrelated features all reach the user through one path, and the user's preferences are honoured in exactly one place.</a:t>
+              <a:t>The point is decoupling: five unrelated features reach the user through one path, and preferences are honoured in exactly one place.</a:t>
             </a:r>
             <a:endParaRPr lang="en-US" dirty="0"/>
           </a:p>
@@ -2094,7 +2094,7 @@
                 <a:ea typeface="Calibri" pitchFamily="34" charset="-122"/>
                 <a:cs typeface="Calibri" pitchFamily="34" charset="-120"/>
               </a:rPr>
-              <a:t>Book exact time slots  ·  message your shop  ·  run the whole business from one app</a:t>
+              <a:t>Book exact time slots  ·  verified reviews  ·  run the whole business from one app</a:t>
             </a:r>
             <a:endParaRPr lang="en-US" sz="1400" dirty="0"/>
           </a:p>
@@ -2197,7 +2197,7 @@
                 <a:ea typeface="Calibri" pitchFamily="34" charset="-122"/>
                 <a:cs typeface="Calibri" pitchFamily="34" charset="-120"/>
               </a:rPr>
-              <a:t>PAYMENTS</a:t>
+              <a:t>REVENUE</a:t>
             </a:r>
             <a:endParaRPr lang="en-US" sz="1200" dirty="0"/>
           </a:p>
@@ -2236,7 +2236,7 @@
                 <a:ea typeface="Cambria" pitchFamily="34" charset="-122"/>
                 <a:cs typeface="Cambria" pitchFamily="34" charset="-120"/>
               </a:rPr>
-              <a:t>Recording money, honestly</a:t>
+              <a:t>Counting money, honestly</a:t>
             </a:r>
             <a:endParaRPr lang="en-US" sz="3400" dirty="0"/>
           </a:p>
@@ -2302,7 +2302,7 @@
                 <a:ea typeface="Calibri" pitchFamily="34" charset="-122"/>
                 <a:cs typeface="Calibri" pitchFamily="34" charset="-120"/>
               </a:rPr>
-              <a:t>What actually happens</a:t>
+              <a:t>The dashboard figure</a:t>
             </a:r>
             <a:endParaRPr lang="en-US" sz="1400" dirty="0"/>
           </a:p>
@@ -2317,16 +2317,16 @@
         <p:spPr>
           <a:xfrm>
             <a:off x="914400" y="2240280"/>
-            <a:ext cx="4709160" cy="914400"/>
-          </a:xfrm>
-          <a:prstGeom prst="rect">
-            <a:avLst/>
-          </a:prstGeom>
-          <a:noFill/>
-          <a:ln/>
-        </p:spPr>
-        <p:txBody>
-          <a:bodyPr wrap="square" lIns="0" tIns="0" rIns="0" bIns="0" rtlCol="0" anchor="ctr"/>
+            <a:ext cx="4709160" cy="868680"/>
+          </a:xfrm>
+          <a:prstGeom prst="rect">
+            <a:avLst/>
+          </a:prstGeom>
+          <a:noFill/>
+          <a:ln/>
+        </p:spPr>
+        <p:txBody>
+          <a:bodyPr wrap="square" lIns="0" tIns="0" rIns="0" bIns="0" rtlCol="0" anchor="t"/>
           <a:lstStyle/>
           <a:p>
             <a:pPr indent="0" marL="0">
@@ -2341,7 +2341,7 @@
                 <a:ea typeface="Calibri" pitchFamily="34" charset="-122"/>
                 <a:cs typeface="Calibri" pitchFamily="34" charset="-120"/>
               </a:rPr>
-              <a:t>Money changes hands at the shop — cash, a mobile money transfer, or a card terminal. The owner records what was taken; StyleBook never touches the transaction.</a:t>
+              <a:t>Revenue is totalled from completed bookings, so it appears without the owner recording anything. The label says Revenue, not Earned.</a:t>
             </a:r>
             <a:endParaRPr lang="en-US" sz="1250" dirty="0"/>
           </a:p>
@@ -2355,17 +2355,17 @@
         </p:nvSpPr>
         <p:spPr>
           <a:xfrm>
-            <a:off x="914400" y="3154680"/>
-            <a:ext cx="4709160" cy="685800"/>
-          </a:xfrm>
-          <a:prstGeom prst="rect">
-            <a:avLst/>
-          </a:prstGeom>
-          <a:noFill/>
-          <a:ln/>
-        </p:spPr>
-        <p:txBody>
-          <a:bodyPr wrap="square" lIns="0" tIns="0" rIns="0" bIns="0" rtlCol="0" anchor="ctr"/>
+            <a:off x="914400" y="3108960"/>
+            <a:ext cx="4709160" cy="777240"/>
+          </a:xfrm>
+          <a:prstGeom prst="rect">
+            <a:avLst/>
+          </a:prstGeom>
+          <a:noFill/>
+          <a:ln/>
+        </p:spPr>
+        <p:txBody>
+          <a:bodyPr wrap="square" lIns="0" tIns="0" rIns="0" bIns="0" rtlCol="0" anchor="t"/>
           <a:lstStyle/>
           <a:p>
             <a:pPr indent="0" marL="0">
@@ -2380,7 +2380,7 @@
                 <a:ea typeface="Calibri" pitchFamily="34" charset="-122"/>
                 <a:cs typeface="Calibri" pitchFamily="34" charset="-120"/>
               </a:rPr>
-              <a:t>That is a deliberate scope decision, not a missing feature — handling other people's money needs a licensed processor.</a:t>
+              <a:t>That wording is deliberate: a booking completes when its end time passes, which is not the same as knowing the customer arrived and paid.</a:t>
             </a:r>
             <a:endParaRPr lang="en-US" sz="1150" dirty="0"/>
           </a:p>
@@ -2389,6 +2389,150 @@
       <p:sp>
         <p:nvSpPr>
           <p:cNvPr id="8" name="Shape 6"/>
+          <p:cNvSpPr/>
+          <p:nvPr/>
+        </p:nvSpPr>
+        <p:spPr>
+          <a:xfrm>
+            <a:off x="6217920" y="1691640"/>
+            <a:ext cx="5349240" cy="2286000"/>
+          </a:xfrm>
+          <a:prstGeom prst="roundRect">
+            <a:avLst>
+              <a:gd name="adj" fmla="val 4000"/>
+            </a:avLst>
+          </a:prstGeom>
+          <a:solidFill>
+            <a:srgbClr val="241A10"/>
+          </a:solidFill>
+          <a:ln w="12700">
+            <a:solidFill>
+              <a:srgbClr val="241A10"/>
+            </a:solidFill>
+            <a:prstDash val="solid"/>
+          </a:ln>
+        </p:spPr>
+      </p:sp>
+      <p:sp>
+        <p:nvSpPr>
+          <p:cNvPr id="9" name="Text 7"/>
+          <p:cNvSpPr/>
+          <p:nvPr/>
+        </p:nvSpPr>
+        <p:spPr>
+          <a:xfrm>
+            <a:off x="6537960" y="1874520"/>
+            <a:ext cx="4754880" cy="320040"/>
+          </a:xfrm>
+          <a:prstGeom prst="rect">
+            <a:avLst/>
+          </a:prstGeom>
+          <a:noFill/>
+          <a:ln/>
+        </p:spPr>
+        <p:txBody>
+          <a:bodyPr wrap="square" lIns="0" tIns="0" rIns="0" bIns="0" rtlCol="0" anchor="ctr"/>
+          <a:lstStyle/>
+          <a:p>
+            <a:pPr indent="0" marL="0">
+              <a:buNone/>
+            </a:pPr>
+            <a:r>
+              <a:rPr lang="en-US" sz="1400" b="1" dirty="0">
+                <a:solidFill>
+                  <a:srgbClr val="C9A227"/>
+                </a:solidFill>
+                <a:latin typeface="Calibri" pitchFamily="34" charset="0"/>
+                <a:ea typeface="Calibri" pitchFamily="34" charset="-122"/>
+                <a:cs typeface="Calibri" pitchFamily="34" charset="-120"/>
+              </a:rPr>
+              <a:t>StyleBook does not process payments</a:t>
+            </a:r>
+            <a:endParaRPr lang="en-US" sz="1400" dirty="0"/>
+          </a:p>
+        </p:txBody>
+      </p:sp>
+      <p:sp>
+        <p:nvSpPr>
+          <p:cNvPr id="10" name="Text 8"/>
+          <p:cNvSpPr/>
+          <p:nvPr/>
+        </p:nvSpPr>
+        <p:spPr>
+          <a:xfrm>
+            <a:off x="6537960" y="2240280"/>
+            <a:ext cx="4709160" cy="1097280"/>
+          </a:xfrm>
+          <a:prstGeom prst="rect">
+            <a:avLst/>
+          </a:prstGeom>
+          <a:noFill/>
+          <a:ln/>
+        </p:spPr>
+        <p:txBody>
+          <a:bodyPr wrap="square" lIns="0" tIns="0" rIns="0" bIns="0" rtlCol="0" anchor="t"/>
+          <a:lstStyle/>
+          <a:p>
+            <a:pPr indent="0" marL="0">
+              <a:buNone/>
+            </a:pPr>
+            <a:r>
+              <a:rPr lang="en-US" sz="1250" dirty="0">
+                <a:solidFill>
+                  <a:srgbClr val="E8DCC9"/>
+                </a:solidFill>
+                <a:latin typeface="Calibri" pitchFamily="34" charset="0"/>
+                <a:ea typeface="Calibri" pitchFamily="34" charset="-122"/>
+                <a:cs typeface="Calibri" pitchFamily="34" charset="-120"/>
+              </a:rPr>
+              <a:t>Money changes hands at the shop — cash, a mobile money transfer, or a card terminal. An owner may optionally record what was taken, which stores the method and emails the customer a receipt.</a:t>
+            </a:r>
+            <a:endParaRPr lang="en-US" sz="1250" dirty="0"/>
+          </a:p>
+        </p:txBody>
+      </p:sp>
+      <p:sp>
+        <p:nvSpPr>
+          <p:cNvPr id="11" name="Text 9"/>
+          <p:cNvSpPr/>
+          <p:nvPr/>
+        </p:nvSpPr>
+        <p:spPr>
+          <a:xfrm>
+            <a:off x="6537960" y="3291840"/>
+            <a:ext cx="4709160" cy="594360"/>
+          </a:xfrm>
+          <a:prstGeom prst="rect">
+            <a:avLst/>
+          </a:prstGeom>
+          <a:noFill/>
+          <a:ln/>
+        </p:spPr>
+        <p:txBody>
+          <a:bodyPr wrap="square" lIns="0" tIns="0" rIns="0" bIns="0" rtlCol="0" anchor="t"/>
+          <a:lstStyle/>
+          <a:p>
+            <a:pPr indent="0" marL="0">
+              <a:buNone/>
+            </a:pPr>
+            <a:r>
+              <a:rPr lang="en-US" sz="1150" i="1" dirty="0">
+                <a:solidFill>
+                  <a:srgbClr val="C9A227"/>
+                </a:solidFill>
+                <a:latin typeface="Calibri" pitchFamily="34" charset="0"/>
+                <a:ea typeface="Calibri" pitchFamily="34" charset="-122"/>
+                <a:cs typeface="Calibri" pitchFamily="34" charset="-120"/>
+              </a:rPr>
+              <a:t>A deliberate scope boundary — handling other people's money needs a licensed processor.</a:t>
+            </a:r>
+            <a:endParaRPr lang="en-US" sz="1150" dirty="0"/>
+          </a:p>
+        </p:txBody>
+      </p:sp>
+      <p:sp>
+        <p:nvSpPr>
+          <p:cNvPr id="12" name="Shape 10"/>
           <p:cNvSpPr/>
           <p:nvPr/>
         </p:nvSpPr>
@@ -2415,7 +2559,7 @@
       </p:sp>
       <p:sp>
         <p:nvSpPr>
-          <p:cNvPr id="9" name="Shape 7"/>
+          <p:cNvPr id="13" name="Shape 11"/>
           <p:cNvSpPr/>
           <p:nvPr/>
         </p:nvSpPr>
@@ -2435,7 +2579,7 @@
       </p:sp>
       <p:sp>
         <p:nvSpPr>
-          <p:cNvPr id="10" name="Text 8"/>
+          <p:cNvPr id="14" name="Text 12"/>
           <p:cNvSpPr/>
           <p:nvPr/>
         </p:nvSpPr>
@@ -2474,7 +2618,7 @@
       </p:sp>
       <p:sp>
         <p:nvSpPr>
-          <p:cNvPr id="11" name="Text 9"/>
+          <p:cNvPr id="15" name="Text 13"/>
           <p:cNvSpPr/>
           <p:nvPr/>
         </p:nvSpPr>
@@ -2497,7 +2641,7 @@
               <a:buNone/>
             </a:pPr>
             <a:r>
-              <a:rPr lang="en-US" sz="1250" b="1" dirty="0">
+              <a:rPr lang="en-US" sz="1200" b="1" dirty="0">
                 <a:solidFill>
                   <a:srgbClr val="2B2118"/>
                 </a:solidFill>
@@ -2505,15 +2649,15 @@
                 <a:ea typeface="Calibri" pitchFamily="34" charset="-122"/>
                 <a:cs typeface="Calibri" pitchFamily="34" charset="-120"/>
               </a:rPr>
-              <a:t>Owner marks paid</a:t>
-            </a:r>
-            <a:endParaRPr lang="en-US" sz="1250" dirty="0"/>
-          </a:p>
-        </p:txBody>
-      </p:sp>
-      <p:sp>
-        <p:nvSpPr>
-          <p:cNvPr id="12" name="Text 10"/>
+              <a:t>Appointment ends</a:t>
+            </a:r>
+            <a:endParaRPr lang="en-US" sz="1200" dirty="0"/>
+          </a:p>
+        </p:txBody>
+      </p:sp>
+      <p:sp>
+        <p:nvSpPr>
+          <p:cNvPr id="16" name="Text 14"/>
           <p:cNvSpPr/>
           <p:nvPr/>
         </p:nvSpPr>
@@ -2529,7 +2673,7 @@
           <a:ln/>
         </p:spPr>
         <p:txBody>
-          <a:bodyPr wrap="square" lIns="0" tIns="0" rIns="0" bIns="0" rtlCol="0" anchor="ctr"/>
+          <a:bodyPr wrap="square" lIns="0" tIns="0" rIns="0" bIns="0" rtlCol="0" anchor="t"/>
           <a:lstStyle/>
           <a:p>
             <a:pPr indent="0" marL="0">
@@ -2544,7 +2688,7 @@
                 <a:ea typeface="Calibri" pitchFamily="34" charset="-122"/>
                 <a:cs typeface="Calibri" pitchFamily="34" charset="-120"/>
               </a:rPr>
-              <a:t>Cash · Mobile Money · Card, defaulting to the listed price</a:t>
+              <a:t>Scheduler marks the booking COMPLETED</a:t>
             </a:r>
             <a:endParaRPr lang="en-US" sz="1050" dirty="0"/>
           </a:p>
@@ -2552,7 +2696,7 @@
       </p:sp>
       <p:sp>
         <p:nvSpPr>
-          <p:cNvPr id="13" name="Shape 11"/>
+          <p:cNvPr id="17" name="Shape 15"/>
           <p:cNvSpPr/>
           <p:nvPr/>
         </p:nvSpPr>
@@ -2579,7 +2723,7 @@
       </p:sp>
       <p:sp>
         <p:nvSpPr>
-          <p:cNvPr id="14" name="Shape 12"/>
+          <p:cNvPr id="18" name="Shape 16"/>
           <p:cNvSpPr/>
           <p:nvPr/>
         </p:nvSpPr>
@@ -2599,7 +2743,7 @@
       </p:sp>
       <p:sp>
         <p:nvSpPr>
-          <p:cNvPr id="15" name="Text 13"/>
+          <p:cNvPr id="19" name="Text 17"/>
           <p:cNvSpPr/>
           <p:nvPr/>
         </p:nvSpPr>
@@ -2638,7 +2782,7 @@
       </p:sp>
       <p:sp>
         <p:nvSpPr>
-          <p:cNvPr id="16" name="Text 14"/>
+          <p:cNvPr id="20" name="Text 18"/>
           <p:cNvSpPr/>
           <p:nvPr/>
         </p:nvSpPr>
@@ -2661,7 +2805,7 @@
               <a:buNone/>
             </a:pPr>
             <a:r>
-              <a:rPr lang="en-US" sz="1250" b="1" dirty="0">
+              <a:rPr lang="en-US" sz="1200" b="1" dirty="0">
                 <a:solidFill>
                   <a:srgbClr val="2B2118"/>
                 </a:solidFill>
@@ -2669,15 +2813,15 @@
                 <a:ea typeface="Calibri" pitchFamily="34" charset="-122"/>
                 <a:cs typeface="Calibri" pitchFamily="34" charset="-120"/>
               </a:rPr>
-              <a:t>Booking settles</a:t>
-            </a:r>
-            <a:endParaRPr lang="en-US" sz="1250" dirty="0"/>
-          </a:p>
-        </p:txBody>
-      </p:sp>
-      <p:sp>
-        <p:nvSpPr>
-          <p:cNvPr id="17" name="Text 15"/>
+              <a:t>Revenue updates</a:t>
+            </a:r>
+            <a:endParaRPr lang="en-US" sz="1200" dirty="0"/>
+          </a:p>
+        </p:txBody>
+      </p:sp>
+      <p:sp>
+        <p:nvSpPr>
+          <p:cNvPr id="21" name="Text 19"/>
           <p:cNvSpPr/>
           <p:nvPr/>
         </p:nvSpPr>
@@ -2693,7 +2837,7 @@
           <a:ln/>
         </p:spPr>
         <p:txBody>
-          <a:bodyPr wrap="square" lIns="0" tIns="0" rIns="0" bIns="0" rtlCol="0" anchor="ctr"/>
+          <a:bodyPr wrap="square" lIns="0" tIns="0" rIns="0" bIns="0" rtlCol="0" anchor="t"/>
           <a:lstStyle/>
           <a:p>
             <a:pPr indent="0" marL="0">
@@ -2708,7 +2852,7 @@
                 <a:ea typeface="Calibri" pitchFamily="34" charset="-122"/>
                 <a:cs typeface="Calibri" pitchFamily="34" charset="-120"/>
               </a:rPr>
-              <a:t>Marked PAID and COMPLETED in one transaction</a:t>
+              <a:t>Totalled on the dashboard, no action needed</a:t>
             </a:r>
             <a:endParaRPr lang="en-US" sz="1050" dirty="0"/>
           </a:p>
@@ -2716,7 +2860,7 @@
       </p:sp>
       <p:sp>
         <p:nvSpPr>
-          <p:cNvPr id="18" name="Shape 16"/>
+          <p:cNvPr id="22" name="Shape 20"/>
           <p:cNvSpPr/>
           <p:nvPr/>
         </p:nvSpPr>
@@ -2743,7 +2887,7 @@
       </p:sp>
       <p:sp>
         <p:nvSpPr>
-          <p:cNvPr id="19" name="Shape 17"/>
+          <p:cNvPr id="23" name="Shape 21"/>
           <p:cNvSpPr/>
           <p:nvPr/>
         </p:nvSpPr>
@@ -2763,7 +2907,7 @@
       </p:sp>
       <p:sp>
         <p:nvSpPr>
-          <p:cNvPr id="20" name="Text 18"/>
+          <p:cNvPr id="24" name="Text 22"/>
           <p:cNvSpPr/>
           <p:nvPr/>
         </p:nvSpPr>
@@ -2802,7 +2946,7 @@
       </p:sp>
       <p:sp>
         <p:nvSpPr>
-          <p:cNvPr id="21" name="Text 19"/>
+          <p:cNvPr id="25" name="Text 23"/>
           <p:cNvSpPr/>
           <p:nvPr/>
         </p:nvSpPr>
@@ -2825,7 +2969,7 @@
               <a:buNone/>
             </a:pPr>
             <a:r>
-              <a:rPr lang="en-US" sz="1250" b="1" dirty="0">
+              <a:rPr lang="en-US" sz="1200" b="1" dirty="0">
                 <a:solidFill>
                   <a:srgbClr val="2B2118"/>
                 </a:solidFill>
@@ -2833,15 +2977,15 @@
                 <a:ea typeface="Calibri" pitchFamily="34" charset="-122"/>
                 <a:cs typeface="Calibri" pitchFamily="34" charset="-120"/>
               </a:rPr>
-              <a:t>Customer is told</a:t>
-            </a:r>
-            <a:endParaRPr lang="en-US" sz="1250" dirty="0"/>
-          </a:p>
-        </p:txBody>
-      </p:sp>
-      <p:sp>
-        <p:nvSpPr>
-          <p:cNvPr id="22" name="Text 20"/>
+              <a:t>Optional: record it</a:t>
+            </a:r>
+            <a:endParaRPr lang="en-US" sz="1200" dirty="0"/>
+          </a:p>
+        </p:txBody>
+      </p:sp>
+      <p:sp>
+        <p:nvSpPr>
+          <p:cNvPr id="26" name="Text 24"/>
           <p:cNvSpPr/>
           <p:nvPr/>
         </p:nvSpPr>
@@ -2857,7 +3001,7 @@
           <a:ln/>
         </p:spPr>
         <p:txBody>
-          <a:bodyPr wrap="square" lIns="0" tIns="0" rIns="0" bIns="0" rtlCol="0" anchor="ctr"/>
+          <a:bodyPr wrap="square" lIns="0" tIns="0" rIns="0" bIns="0" rtlCol="0" anchor="t"/>
           <a:lstStyle/>
           <a:p>
             <a:pPr indent="0" marL="0">
@@ -2872,7 +3016,7 @@
                 <a:ea typeface="Calibri" pitchFamily="34" charset="-122"/>
                 <a:cs typeface="Calibri" pitchFamily="34" charset="-120"/>
               </a:rPr>
-              <a:t>Push notification and an emailed receipt via SendGrid</a:t>
+              <a:t>Cash · Mobile Money · Card, if the owner has a moment</a:t>
             </a:r>
             <a:endParaRPr lang="en-US" sz="1050" dirty="0"/>
           </a:p>
@@ -2880,7 +3024,7 @@
       </p:sp>
       <p:sp>
         <p:nvSpPr>
-          <p:cNvPr id="23" name="Shape 21"/>
+          <p:cNvPr id="27" name="Shape 25"/>
           <p:cNvSpPr/>
           <p:nvPr/>
         </p:nvSpPr>
@@ -2907,7 +3051,7 @@
       </p:sp>
       <p:sp>
         <p:nvSpPr>
-          <p:cNvPr id="24" name="Shape 22"/>
+          <p:cNvPr id="28" name="Shape 26"/>
           <p:cNvSpPr/>
           <p:nvPr/>
         </p:nvSpPr>
@@ -2927,7 +3071,7 @@
       </p:sp>
       <p:sp>
         <p:nvSpPr>
-          <p:cNvPr id="25" name="Text 23"/>
+          <p:cNvPr id="29" name="Text 27"/>
           <p:cNvSpPr/>
           <p:nvPr/>
         </p:nvSpPr>
@@ -2966,7 +3110,7 @@
       </p:sp>
       <p:sp>
         <p:nvSpPr>
-          <p:cNvPr id="26" name="Text 24"/>
+          <p:cNvPr id="30" name="Text 28"/>
           <p:cNvSpPr/>
           <p:nvPr/>
         </p:nvSpPr>
@@ -2989,7 +3133,7 @@
               <a:buNone/>
             </a:pPr>
             <a:r>
-              <a:rPr lang="en-US" sz="1250" b="1" dirty="0">
+              <a:rPr lang="en-US" sz="1200" b="1" dirty="0">
                 <a:solidFill>
                   <a:srgbClr val="C9A227"/>
                 </a:solidFill>
@@ -2997,15 +3141,15 @@
                 <a:ea typeface="Calibri" pitchFamily="34" charset="-122"/>
                 <a:cs typeface="Calibri" pitchFamily="34" charset="-120"/>
               </a:rPr>
-              <a:t>Dashboard updates</a:t>
-            </a:r>
-            <a:endParaRPr lang="en-US" sz="1250" dirty="0"/>
-          </a:p>
-        </p:txBody>
-      </p:sp>
-      <p:sp>
-        <p:nvSpPr>
-          <p:cNvPr id="27" name="Text 25"/>
+              <a:t>Customer gets a receipt</a:t>
+            </a:r>
+            <a:endParaRPr lang="en-US" sz="1200" dirty="0"/>
+          </a:p>
+        </p:txBody>
+      </p:sp>
+      <p:sp>
+        <p:nvSpPr>
+          <p:cNvPr id="31" name="Text 29"/>
           <p:cNvSpPr/>
           <p:nvPr/>
         </p:nvSpPr>
@@ -3021,7 +3165,7 @@
           <a:ln/>
         </p:spPr>
         <p:txBody>
-          <a:bodyPr wrap="square" lIns="0" tIns="0" rIns="0" bIns="0" rtlCol="0" anchor="ctr"/>
+          <a:bodyPr wrap="square" lIns="0" tIns="0" rIns="0" bIns="0" rtlCol="0" anchor="t"/>
           <a:lstStyle/>
           <a:p>
             <a:pPr indent="0" marL="0">
@@ -3036,153 +3180,9 @@
                 <a:ea typeface="Calibri" pitchFamily="34" charset="-122"/>
                 <a:cs typeface="Calibri" pitchFamily="34" charset="-120"/>
               </a:rPr>
-              <a:t>Earnings this month, from payments actually recorded</a:t>
+              <a:t>Push notification and an emailed record</a:t>
             </a:r>
             <a:endParaRPr lang="en-US" sz="1050" dirty="0"/>
-          </a:p>
-        </p:txBody>
-      </p:sp>
-      <p:sp>
-        <p:nvSpPr>
-          <p:cNvPr id="28" name="Shape 26"/>
-          <p:cNvSpPr/>
-          <p:nvPr/>
-        </p:nvSpPr>
-        <p:spPr>
-          <a:xfrm>
-            <a:off x="6217920" y="1691640"/>
-            <a:ext cx="5349240" cy="2286000"/>
-          </a:xfrm>
-          <a:prstGeom prst="roundRect">
-            <a:avLst>
-              <a:gd name="adj" fmla="val 4000"/>
-            </a:avLst>
-          </a:prstGeom>
-          <a:solidFill>
-            <a:srgbClr val="241A10"/>
-          </a:solidFill>
-          <a:ln w="12700">
-            <a:solidFill>
-              <a:srgbClr val="241A10"/>
-            </a:solidFill>
-            <a:prstDash val="solid"/>
-          </a:ln>
-        </p:spPr>
-      </p:sp>
-      <p:sp>
-        <p:nvSpPr>
-          <p:cNvPr id="29" name="Text 27"/>
-          <p:cNvSpPr/>
-          <p:nvPr/>
-        </p:nvSpPr>
-        <p:spPr>
-          <a:xfrm>
-            <a:off x="6537960" y="1874520"/>
-            <a:ext cx="4572000" cy="320040"/>
-          </a:xfrm>
-          <a:prstGeom prst="rect">
-            <a:avLst/>
-          </a:prstGeom>
-          <a:noFill/>
-          <a:ln/>
-        </p:spPr>
-        <p:txBody>
-          <a:bodyPr wrap="square" lIns="0" tIns="0" rIns="0" bIns="0" rtlCol="0" anchor="ctr"/>
-          <a:lstStyle/>
-          <a:p>
-            <a:pPr indent="0" marL="0">
-              <a:buNone/>
-            </a:pPr>
-            <a:r>
-              <a:rPr lang="en-US" sz="1400" b="1" dirty="0">
-                <a:solidFill>
-                  <a:srgbClr val="C9A227"/>
-                </a:solidFill>
-                <a:latin typeface="Calibri" pitchFamily="34" charset="0"/>
-                <a:ea typeface="Calibri" pitchFamily="34" charset="-122"/>
-                <a:cs typeface="Calibri" pitchFamily="34" charset="-120"/>
-              </a:rPr>
-              <a:t>Subscription upgrades</a:t>
-            </a:r>
-            <a:endParaRPr lang="en-US" sz="1400" dirty="0"/>
-          </a:p>
-        </p:txBody>
-      </p:sp>
-      <p:sp>
-        <p:nvSpPr>
-          <p:cNvPr id="30" name="Text 28"/>
-          <p:cNvSpPr/>
-          <p:nvPr/>
-        </p:nvSpPr>
-        <p:spPr>
-          <a:xfrm>
-            <a:off x="6537960" y="2240280"/>
-            <a:ext cx="4709160" cy="914400"/>
-          </a:xfrm>
-          <a:prstGeom prst="rect">
-            <a:avLst/>
-          </a:prstGeom>
-          <a:noFill/>
-          <a:ln/>
-        </p:spPr>
-        <p:txBody>
-          <a:bodyPr wrap="square" lIns="0" tIns="0" rIns="0" bIns="0" rtlCol="0" anchor="ctr"/>
-          <a:lstStyle/>
-          <a:p>
-            <a:pPr indent="0" marL="0">
-              <a:buNone/>
-            </a:pPr>
-            <a:r>
-              <a:rPr lang="en-US" sz="1250" dirty="0">
-                <a:solidFill>
-                  <a:srgbClr val="E8DCC9"/>
-                </a:solidFill>
-                <a:latin typeface="Calibri" pitchFamily="34" charset="0"/>
-                <a:ea typeface="Calibri" pitchFamily="34" charset="-122"/>
-                <a:cs typeface="Calibri" pitchFamily="34" charset="-120"/>
-              </a:rPr>
-              <a:t>Owners upgrade to Pro or Enterprise through a simulated mobile-money or card checkout — network choice, number entry, and an authorisation wait that mirrors a real MoMo prompt.</a:t>
-            </a:r>
-            <a:endParaRPr lang="en-US" sz="1250" dirty="0"/>
-          </a:p>
-        </p:txBody>
-      </p:sp>
-      <p:sp>
-        <p:nvSpPr>
-          <p:cNvPr id="31" name="Text 29"/>
-          <p:cNvSpPr/>
-          <p:nvPr/>
-        </p:nvSpPr>
-        <p:spPr>
-          <a:xfrm>
-            <a:off x="6537960" y="3154680"/>
-            <a:ext cx="4709160" cy="685800"/>
-          </a:xfrm>
-          <a:prstGeom prst="rect">
-            <a:avLst/>
-          </a:prstGeom>
-          <a:noFill/>
-          <a:ln/>
-        </p:spPr>
-        <p:txBody>
-          <a:bodyPr wrap="square" lIns="0" tIns="0" rIns="0" bIns="0" rtlCol="0" anchor="ctr"/>
-          <a:lstStyle/>
-          <a:p>
-            <a:pPr indent="0" marL="0">
-              <a:buNone/>
-            </a:pPr>
-            <a:r>
-              <a:rPr lang="en-US" sz="1150" i="1" dirty="0">
-                <a:solidFill>
-                  <a:srgbClr val="C9A227"/>
-                </a:solidFill>
-                <a:latin typeface="Calibri" pitchFamily="34" charset="0"/>
-                <a:ea typeface="Calibri" pitchFamily="34" charset="-122"/>
-                <a:cs typeface="Calibri" pitchFamily="34" charset="-120"/>
-              </a:rPr>
-              <a:t>Every screen is labelled as a demo. Presenting a fake payment convincingly would be the wrong thing to build.</a:t>
-            </a:r>
-            <a:endParaRPr lang="en-US" sz="1150" dirty="0"/>
           </a:p>
         </p:txBody>
       </p:sp>
@@ -3373,7 +3373,7 @@
           <a:ln/>
         </p:spPr>
         <p:txBody>
-          <a:bodyPr wrap="square" lIns="0" tIns="0" rIns="0" bIns="0" rtlCol="0" anchor="ctr"/>
+          <a:bodyPr wrap="square" lIns="0" tIns="0" rIns="0" bIns="0" rtlCol="0" anchor="t"/>
           <a:lstStyle/>
           <a:p>
             <a:pPr indent="0" marL="0">
@@ -3478,7 +3478,7 @@
           <a:ln/>
         </p:spPr>
         <p:txBody>
-          <a:bodyPr wrap="square" lIns="0" tIns="0" rIns="0" bIns="0" rtlCol="0" anchor="ctr"/>
+          <a:bodyPr wrap="square" lIns="0" tIns="0" rIns="0" bIns="0" rtlCol="0" anchor="t"/>
           <a:lstStyle/>
           <a:p>
             <a:pPr indent="0" marL="0">
@@ -3583,7 +3583,7 @@
           <a:ln/>
         </p:spPr>
         <p:txBody>
-          <a:bodyPr wrap="square" lIns="0" tIns="0" rIns="0" bIns="0" rtlCol="0" anchor="ctr"/>
+          <a:bodyPr wrap="square" lIns="0" tIns="0" rIns="0" bIns="0" rtlCol="0" anchor="t"/>
           <a:lstStyle/>
           <a:p>
             <a:pPr indent="0" marL="0">
@@ -3688,7 +3688,7 @@
           <a:ln/>
         </p:spPr>
         <p:txBody>
-          <a:bodyPr wrap="square" lIns="0" tIns="0" rIns="0" bIns="0" rtlCol="0" anchor="ctr"/>
+          <a:bodyPr wrap="square" lIns="0" tIns="0" rIns="0" bIns="0" rtlCol="0" anchor="t"/>
           <a:lstStyle/>
           <a:p>
             <a:pPr indent="0" marL="0">
@@ -3808,7 +3808,7 @@
                 <a:ea typeface="Calibri" pitchFamily="34" charset="-122"/>
                 <a:cs typeface="Calibri" pitchFamily="34" charset="-120"/>
               </a:rPr>
-              <a:t>Slot availability, double bookings, review eligibility, photo limits, chat membership — the app is a window, not a judge.</a:t>
+              <a:t>Slot availability, double bookings, review eligibility, photo limits — the app is a window, not a judge.</a:t>
             </a:r>
             <a:endParaRPr lang="en-US" sz="1350" dirty="0"/>
           </a:p>
@@ -4060,7 +4060,7 @@
           <a:ln/>
         </p:spPr>
         <p:txBody>
-          <a:bodyPr wrap="square" lIns="0" tIns="0" rIns="0" bIns="0" rtlCol="0" anchor="ctr"/>
+          <a:bodyPr wrap="square" lIns="0" tIns="0" rIns="0" bIns="0" rtlCol="0" anchor="t"/>
           <a:lstStyle/>
           <a:p>
             <a:pPr indent="0" marL="0">
@@ -4290,7 +4290,7 @@
           <a:ln/>
         </p:spPr>
         <p:txBody>
-          <a:bodyPr wrap="square" lIns="0" tIns="0" rIns="0" bIns="0" rtlCol="0" anchor="ctr"/>
+          <a:bodyPr wrap="square" lIns="0" tIns="0" rIns="0" bIns="0" rtlCol="0" anchor="t"/>
           <a:lstStyle/>
           <a:p>
             <a:pPr indent="0" marL="0">
@@ -4520,7 +4520,7 @@
           <a:ln/>
         </p:spPr>
         <p:txBody>
-          <a:bodyPr wrap="square" lIns="0" tIns="0" rIns="0" bIns="0" rtlCol="0" anchor="ctr"/>
+          <a:bodyPr wrap="square" lIns="0" tIns="0" rIns="0" bIns="0" rtlCol="0" anchor="t"/>
           <a:lstStyle/>
           <a:p>
             <a:pPr indent="0" marL="0">
@@ -4535,7 +4535,7 @@
                 <a:ea typeface="Calibri" pitchFamily="34" charset="-122"/>
                 <a:cs typeface="Calibri" pitchFamily="34" charset="-120"/>
               </a:rPr>
-              <a:t>Merged code kept not appearing live. Railway had auto-deploy disabled, so it was restarting an old image — the running container's repository count gave it away.</a:t>
+              <a:t>Merged code kept not appearing live. Auto-deploy was disabled, so the platform kept restarting an old image — the running container's repository count gave it away.</a:t>
             </a:r>
             <a:endParaRPr lang="en-US" sz="1150" dirty="0"/>
           </a:p>
@@ -4868,7 +4868,7 @@
                 <a:ea typeface="Calibri" pitchFamily="34" charset="-122"/>
                 <a:cs typeface="Calibri" pitchFamily="34" charset="-120"/>
               </a:rPr>
-              <a:t>Real mobile money</a:t>
+              <a:t>Attendance check-in</a:t>
             </a:r>
             <a:endParaRPr lang="en-US" sz="1500" dirty="0"/>
           </a:p>
@@ -4892,7 +4892,7 @@
           <a:ln/>
         </p:spPr>
         <p:txBody>
-          <a:bodyPr wrap="square" lIns="0" tIns="0" rIns="0" bIns="0" rtlCol="0" anchor="ctr"/>
+          <a:bodyPr wrap="square" lIns="0" tIns="0" rIns="0" bIns="0" rtlCol="0" anchor="t"/>
           <a:lstStyle/>
           <a:p>
             <a:pPr indent="0" marL="0">
@@ -4907,7 +4907,7 @@
                 <a:ea typeface="Calibri" pitchFamily="34" charset="-122"/>
                 <a:cs typeface="Calibri" pitchFamily="34" charset="-120"/>
               </a:rPr>
-              <a:t>Paystack or Hubtel with a settlement webhook, replacing the simulated checkout</a:t>
+              <a:t>A customer or owner confirmation, so completion is known rather than inferred</a:t>
             </a:r>
             <a:endParaRPr lang="en-US" sz="1150" dirty="0"/>
           </a:p>
@@ -5005,7 +5005,7 @@
                 <a:ea typeface="Calibri" pitchFamily="34" charset="-122"/>
                 <a:cs typeface="Calibri" pitchFamily="34" charset="-120"/>
               </a:rPr>
-              <a:t>Persistent media storage</a:t>
+              <a:t>Real mobile money</a:t>
             </a:r>
             <a:endParaRPr lang="en-US" sz="1500" dirty="0"/>
           </a:p>
@@ -5029,7 +5029,7 @@
           <a:ln/>
         </p:spPr>
         <p:txBody>
-          <a:bodyPr wrap="square" lIns="0" tIns="0" rIns="0" bIns="0" rtlCol="0" anchor="ctr"/>
+          <a:bodyPr wrap="square" lIns="0" tIns="0" rIns="0" bIns="0" rtlCol="0" anchor="t"/>
           <a:lstStyle/>
           <a:p>
             <a:pPr indent="0" marL="0">
@@ -5044,7 +5044,7 @@
                 <a:ea typeface="Calibri" pitchFamily="34" charset="-122"/>
                 <a:cs typeface="Calibri" pitchFamily="34" charset="-120"/>
               </a:rPr>
-              <a:t>A mounted volume or object storage, so uploads survive a redeploy</a:t>
+              <a:t>Paystack or Hubtel with a settlement webhook, replacing the simulated checkout</a:t>
             </a:r>
             <a:endParaRPr lang="en-US" sz="1150" dirty="0"/>
           </a:p>
@@ -5142,7 +5142,7 @@
                 <a:ea typeface="Calibri" pitchFamily="34" charset="-122"/>
                 <a:cs typeface="Calibri" pitchFamily="34" charset="-120"/>
               </a:rPr>
-              <a:t>Staff-level calendars</a:t>
+              <a:t>Persistent media storage</a:t>
             </a:r>
             <a:endParaRPr lang="en-US" sz="1500" dirty="0"/>
           </a:p>
@@ -5166,7 +5166,7 @@
           <a:ln/>
         </p:spPr>
         <p:txBody>
-          <a:bodyPr wrap="square" lIns="0" tIns="0" rIns="0" bIns="0" rtlCol="0" anchor="ctr"/>
+          <a:bodyPr wrap="square" lIns="0" tIns="0" rIns="0" bIns="0" rtlCol="0" anchor="t"/>
           <a:lstStyle/>
           <a:p>
             <a:pPr indent="0" marL="0">
@@ -5181,7 +5181,7 @@
                 <a:ea typeface="Calibri" pitchFamily="34" charset="-122"/>
                 <a:cs typeface="Calibri" pitchFamily="34" charset="-120"/>
               </a:rPr>
-              <a:t>Book a specific barber, each with their own schedule</a:t>
+              <a:t>A mounted volume or object storage, so uploads survive a redeploy</a:t>
             </a:r>
             <a:endParaRPr lang="en-US" sz="1150" dirty="0"/>
           </a:p>
@@ -5303,7 +5303,7 @@
           <a:ln/>
         </p:spPr>
         <p:txBody>
-          <a:bodyPr wrap="square" lIns="0" tIns="0" rIns="0" bIns="0" rtlCol="0" anchor="ctr"/>
+          <a:bodyPr wrap="square" lIns="0" tIns="0" rIns="0" bIns="0" rtlCol="0" anchor="t"/>
           <a:lstStyle/>
           <a:p>
             <a:pPr indent="0" marL="0">
@@ -6290,7 +6290,7 @@
           <a:ln/>
         </p:spPr>
         <p:txBody>
-          <a:bodyPr wrap="square" lIns="0" tIns="0" rIns="0" bIns="0" rtlCol="0" anchor="ctr"/>
+          <a:bodyPr wrap="square" lIns="0" tIns="0" rIns="0" bIns="0" rtlCol="0" anchor="t"/>
           <a:lstStyle/>
           <a:p>
             <a:pPr marL="342900" indent="-342900">
@@ -6372,7 +6372,7 @@
                 <a:ea typeface="Calibri" pitchFamily="34" charset="-122"/>
                 <a:cs typeface="Calibri" pitchFamily="34" charset="-120"/>
               </a:rPr>
-              <a:t>Message a shop directly and get replies by push</a:t>
+              <a:t>Reminders, reschedule, favourites, feed of shop posts</a:t>
             </a:r>
             <a:endParaRPr lang="en-US" sz="1350" dirty="0"/>
           </a:p>
@@ -6393,7 +6393,7 @@
                 <a:ea typeface="Calibri" pitchFamily="34" charset="-122"/>
                 <a:cs typeface="Calibri" pitchFamily="34" charset="-120"/>
               </a:rPr>
-              <a:t>Reminders, reschedule, favourites, feed of shop posts</a:t>
+              <a:t>Push notifications for every booking change</a:t>
             </a:r>
             <a:endParaRPr lang="en-US" sz="1350" dirty="0"/>
           </a:p>
@@ -6414,7 +6414,7 @@
                 <a:ea typeface="Calibri" pitchFamily="34" charset="-122"/>
                 <a:cs typeface="Calibri" pitchFamily="34" charset="-120"/>
               </a:rPr>
-              <a:t>Emailed receipt whenever a shop records a payment</a:t>
+              <a:t>Emailed receipt when a shop records a payment</a:t>
             </a:r>
             <a:endParaRPr lang="en-US" sz="1350" dirty="0"/>
           </a:p>
@@ -6504,7 +6504,7 @@
           <a:ln/>
         </p:spPr>
         <p:txBody>
-          <a:bodyPr wrap="square" lIns="0" tIns="0" rIns="0" bIns="0" rtlCol="0" anchor="ctr"/>
+          <a:bodyPr wrap="square" lIns="0" tIns="0" rIns="0" bIns="0" rtlCol="0" anchor="t"/>
           <a:lstStyle/>
           <a:p>
             <a:pPr marL="342900" indent="-342900">
@@ -6544,7 +6544,7 @@
                 <a:ea typeface="Calibri" pitchFamily="34" charset="-122"/>
                 <a:cs typeface="Calibri" pitchFamily="34" charset="-120"/>
               </a:rPr>
-              <a:t>Record payments: cash, mobile money or card</a:t>
+              <a:t>Revenue this month, totalled without any manual step</a:t>
             </a:r>
             <a:endParaRPr lang="en-US" sz="1350" dirty="0"/>
           </a:p>
@@ -6565,7 +6565,7 @@
                 <a:ea typeface="Calibri" pitchFamily="34" charset="-122"/>
                 <a:cs typeface="Calibri" pitchFamily="34" charset="-120"/>
               </a:rPr>
-              <a:t>Earnings this month, from payments actually taken</a:t>
+              <a:t>Optional payment recording: cash, mobile money or card</a:t>
             </a:r>
             <a:endParaRPr lang="en-US" sz="1350" dirty="0"/>
           </a:p>
@@ -6586,7 +6586,7 @@
                 <a:ea typeface="Calibri" pitchFamily="34" charset="-122"/>
                 <a:cs typeface="Calibri" pitchFamily="34" charset="-120"/>
               </a:rPr>
-              <a:t>Customer messaging inbox with unread badges</a:t>
+              <a:t>Full shop editor: services, photos, hours, GPS pin</a:t>
             </a:r>
             <a:endParaRPr lang="en-US" sz="1350" dirty="0"/>
           </a:p>
@@ -6607,7 +6607,7 @@
                 <a:ea typeface="Calibri" pitchFamily="34" charset="-122"/>
                 <a:cs typeface="Calibri" pitchFamily="34" charset="-120"/>
               </a:rPr>
-              <a:t>Full shop editor: services, photos, hours, GPS pin</a:t>
+              <a:t>Posts to the customer feed, replies to reviews</a:t>
             </a:r>
             <a:endParaRPr lang="en-US" sz="1350" dirty="0"/>
           </a:p>
@@ -7580,7 +7580,7 @@
                 <a:ea typeface="Calibri" pitchFamily="34" charset="-122"/>
                 <a:cs typeface="Calibri" pitchFamily="34" charset="-120"/>
               </a:rPr>
-              <a:t>Pay &amp; review</a:t>
+              <a:t>Review</a:t>
             </a:r>
             <a:endParaRPr lang="en-US" sz="1500" dirty="0"/>
           </a:p>
@@ -7619,7 +7619,7 @@
                 <a:ea typeface="Calibri" pitchFamily="34" charset="-122"/>
                 <a:cs typeface="Calibri" pitchFamily="34" charset="-120"/>
               </a:rPr>
-              <a:t>Receipt emailed;</a:t>
+              <a:t>Only after the</a:t>
             </a:r>
             <a:endParaRPr lang="en-US" sz="1150" dirty="0"/>
           </a:p>
@@ -7636,7 +7636,7 @@
                 <a:ea typeface="Calibri" pitchFamily="34" charset="-122"/>
                 <a:cs typeface="Calibri" pitchFamily="34" charset="-120"/>
               </a:rPr>
-              <a:t>only real visits review</a:t>
+              <a:t>appointment has passed</a:t>
             </a:r>
             <a:endParaRPr lang="en-US" sz="1150" dirty="0"/>
           </a:p>
@@ -7702,7 +7702,7 @@
                 <a:ea typeface="Calibri" pitchFamily="34" charset="-122"/>
                 <a:cs typeface="Calibri" pitchFamily="34" charset="-120"/>
               </a:rPr>
-              <a:t>Every rule — availability, conflicts, review eligibility, chat membership, plan limits — is enforced by the server, never the phone.</a:t>
+              <a:t>Every rule — availability, conflicts, review eligibility, plan limits — is enforced by the server, never the phone.</a:t>
             </a:r>
             <a:endParaRPr lang="en-US" sz="1450" dirty="0"/>
           </a:p>
@@ -7895,7 +7895,7 @@
           <a:ln/>
         </p:spPr>
         <p:txBody>
-          <a:bodyPr wrap="square" lIns="0" tIns="0" rIns="0" bIns="0" rtlCol="0" anchor="ctr"/>
+          <a:bodyPr wrap="square" lIns="0" tIns="0" rIns="0" bIns="0" rtlCol="0" anchor="t"/>
           <a:lstStyle/>
           <a:p>
             <a:pPr indent="0" marL="0">
@@ -8000,7 +8000,7 @@
           <a:ln/>
         </p:spPr>
         <p:txBody>
-          <a:bodyPr wrap="square" lIns="0" tIns="0" rIns="0" bIns="0" rtlCol="0" anchor="ctr"/>
+          <a:bodyPr wrap="square" lIns="0" tIns="0" rIns="0" bIns="0" rtlCol="0" anchor="t"/>
           <a:lstStyle/>
           <a:p>
             <a:pPr indent="0" marL="0">
@@ -8105,7 +8105,7 @@
           <a:ln/>
         </p:spPr>
         <p:txBody>
-          <a:bodyPr wrap="square" lIns="0" tIns="0" rIns="0" bIns="0" rtlCol="0" anchor="ctr"/>
+          <a:bodyPr wrap="square" lIns="0" tIns="0" rIns="0" bIns="0" rtlCol="0" anchor="t"/>
           <a:lstStyle/>
           <a:p>
             <a:pPr indent="0" marL="0">
@@ -8120,7 +8120,7 @@
                 <a:ea typeface="Calibri" pitchFamily="34" charset="-122"/>
                 <a:cs typeface="Calibri" pitchFamily="34" charset="-120"/>
               </a:rPr>
-              <a:t>17 tables, UUID keys, foreign-key integrity. ACID transactions stop two customers taking the same slot.</a:t>
+              <a:t>15 tables, UUID keys, foreign-key integrity. ACID transactions stop two customers taking the same slot.</a:t>
             </a:r>
             <a:endParaRPr lang="en-US" sz="1150" dirty="0"/>
           </a:p>
@@ -8210,7 +8210,7 @@
           <a:ln/>
         </p:spPr>
         <p:txBody>
-          <a:bodyPr wrap="square" lIns="0" tIns="0" rIns="0" bIns="0" rtlCol="0" anchor="ctr"/>
+          <a:bodyPr wrap="square" lIns="0" tIns="0" rIns="0" bIns="0" rtlCol="0" anchor="t"/>
           <a:lstStyle/>
           <a:p>
             <a:pPr indent="0" marL="0">
@@ -8291,7 +8291,7 @@
                 <a:ea typeface="Calibri" pitchFamily="34" charset="-122"/>
                 <a:cs typeface="Calibri" pitchFamily="34" charset="-120"/>
               </a:rPr>
-              <a:t>STOMP over WebSocket</a:t>
+              <a:t>Expo Push</a:t>
             </a:r>
             <a:endParaRPr lang="en-US" sz="1400" dirty="0"/>
           </a:p>
@@ -8315,7 +8315,7 @@
           <a:ln/>
         </p:spPr>
         <p:txBody>
-          <a:bodyPr wrap="square" lIns="0" tIns="0" rIns="0" bIns="0" rtlCol="0" anchor="ctr"/>
+          <a:bodyPr wrap="square" lIns="0" tIns="0" rIns="0" bIns="0" rtlCol="0" anchor="t"/>
           <a:lstStyle/>
           <a:p>
             <a:pPr indent="0" marL="0">
@@ -8330,7 +8330,7 @@
                 <a:ea typeface="Calibri" pitchFamily="34" charset="-122"/>
                 <a:cs typeface="Calibri" pitchFamily="34" charset="-120"/>
               </a:rPr>
-              <a:t>Live delivery of chat messages and notifications to any app that happens to be open.</a:t>
+              <a:t>Fans out to FCM and APNs, so the server holds no Firebase credentials and the app needs no native config.</a:t>
             </a:r>
             <a:endParaRPr lang="en-US" sz="1150" dirty="0"/>
           </a:p>
@@ -8396,7 +8396,7 @@
                 <a:ea typeface="Calibri" pitchFamily="34" charset="-122"/>
                 <a:cs typeface="Calibri" pitchFamily="34" charset="-120"/>
               </a:rPr>
-              <a:t>Expo Push · SendGrid</a:t>
+              <a:t>SendGrid</a:t>
             </a:r>
             <a:endParaRPr lang="en-US" sz="1400" dirty="0"/>
           </a:p>
@@ -8420,7 +8420,7 @@
           <a:ln/>
         </p:spPr>
         <p:txBody>
-          <a:bodyPr wrap="square" lIns="0" tIns="0" rIns="0" bIns="0" rtlCol="0" anchor="ctr"/>
+          <a:bodyPr wrap="square" lIns="0" tIns="0" rIns="0" bIns="0" rtlCol="0" anchor="t"/>
           <a:lstStyle/>
           <a:p>
             <a:pPr indent="0" marL="0">
@@ -8435,7 +8435,7 @@
                 <a:ea typeface="Calibri" pitchFamily="34" charset="-122"/>
                 <a:cs typeface="Calibri" pitchFamily="34" charset="-120"/>
               </a:rPr>
-              <a:t>Push fans out to FCM and APNs without Firebase credentials; transactional email over HTTPS, not SMTP.</a:t>
+              <a:t>Transactional email over HTTPS rather than SMTP, whose ports hosting platforms commonly block.</a:t>
             </a:r>
             <a:endParaRPr lang="en-US" sz="1150" dirty="0"/>
           </a:p>
@@ -8724,7 +8724,7 @@
         <p:spPr>
           <a:xfrm>
             <a:off x="822960" y="3337560"/>
-            <a:ext cx="2697480" cy="2286000"/>
+            <a:ext cx="2697480" cy="1828800"/>
           </a:xfrm>
           <a:prstGeom prst="rect">
             <a:avLst/>
@@ -8773,7 +8773,7 @@
                 <a:ea typeface="Calibri" pitchFamily="34" charset="-122"/>
                 <a:cs typeface="Calibri" pitchFamily="34" charset="-120"/>
               </a:rPr>
-              <a:t>Services — Auth · Shop · Booking · Review · Post · Promo · Messaging · Notification</a:t>
+              <a:t>Services — Auth · Shop · Booking · Review · Post · Promo · Notification</a:t>
             </a:r>
             <a:endParaRPr lang="en-US" sz="1050" dirty="0"/>
           </a:p>
@@ -8836,7 +8836,7 @@
                 <a:ea typeface="Calibri" pitchFamily="34" charset="-122"/>
                 <a:cs typeface="Calibri" pitchFamily="34" charset="-120"/>
               </a:rPr>
-              <a:t>Listeners — six domain events, one notification pipeline</a:t>
+              <a:t>Listeners — five domain events, one notification pipeline</a:t>
             </a:r>
             <a:endParaRPr lang="en-US" sz="1050" dirty="0"/>
           </a:p>
@@ -8926,7 +8926,7 @@
           <a:ln/>
         </p:spPr>
         <p:txBody>
-          <a:bodyPr wrap="square" lIns="0" tIns="0" rIns="0" bIns="0" rtlCol="0" anchor="ctr"/>
+          <a:bodyPr wrap="square" lIns="0" tIns="0" rIns="0" bIns="0" rtlCol="0" anchor="t"/>
           <a:lstStyle/>
           <a:p>
             <a:pPr indent="0" marL="0">
@@ -8955,12 +8955,12 @@
         </p:nvSpPr>
         <p:spPr>
           <a:xfrm>
-            <a:off x="4206240" y="3310128"/>
-            <a:ext cx="3474720" cy="329184"/>
+            <a:off x="4206240" y="3429000"/>
+            <a:ext cx="3474720" cy="347472"/>
           </a:xfrm>
           <a:prstGeom prst="roundRect">
             <a:avLst>
-              <a:gd name="adj" fmla="val 16667"/>
+              <a:gd name="adj" fmla="val 15789"/>
             </a:avLst>
           </a:prstGeom>
           <a:solidFill>
@@ -8982,8 +8982,8 @@
         </p:nvSpPr>
         <p:spPr>
           <a:xfrm>
-            <a:off x="4343400" y="3310128"/>
-            <a:ext cx="3200400" cy="329184"/>
+            <a:off x="4343400" y="3429000"/>
+            <a:ext cx="3200400" cy="347472"/>
           </a:xfrm>
           <a:prstGeom prst="rect">
             <a:avLst/>
@@ -9021,12 +9021,12 @@
         </p:nvSpPr>
         <p:spPr>
           <a:xfrm>
-            <a:off x="4206240" y="3712464"/>
-            <a:ext cx="3474720" cy="329184"/>
+            <a:off x="4206240" y="3867912"/>
+            <a:ext cx="3474720" cy="347472"/>
           </a:xfrm>
           <a:prstGeom prst="roundRect">
             <a:avLst>
-              <a:gd name="adj" fmla="val 16667"/>
+              <a:gd name="adj" fmla="val 15789"/>
             </a:avLst>
           </a:prstGeom>
           <a:solidFill>
@@ -9048,8 +9048,8 @@
         </p:nvSpPr>
         <p:spPr>
           <a:xfrm>
-            <a:off x="4343400" y="3712464"/>
-            <a:ext cx="3200400" cy="329184"/>
+            <a:off x="4343400" y="3867912"/>
+            <a:ext cx="3200400" cy="347472"/>
           </a:xfrm>
           <a:prstGeom prst="rect">
             <a:avLst/>
@@ -9087,12 +9087,12 @@
         </p:nvSpPr>
         <p:spPr>
           <a:xfrm>
-            <a:off x="4206240" y="4114800"/>
-            <a:ext cx="3474720" cy="329184"/>
+            <a:off x="4206240" y="4306824"/>
+            <a:ext cx="3474720" cy="347472"/>
           </a:xfrm>
           <a:prstGeom prst="roundRect">
             <a:avLst>
-              <a:gd name="adj" fmla="val 16667"/>
+              <a:gd name="adj" fmla="val 15789"/>
             </a:avLst>
           </a:prstGeom>
           <a:solidFill>
@@ -9114,8 +9114,8 @@
         </p:nvSpPr>
         <p:spPr>
           <a:xfrm>
-            <a:off x="4343400" y="4114800"/>
-            <a:ext cx="3200400" cy="329184"/>
+            <a:off x="4343400" y="4306824"/>
+            <a:ext cx="3200400" cy="347472"/>
           </a:xfrm>
           <a:prstGeom prst="rect">
             <a:avLst/>
@@ -9153,12 +9153,12 @@
         </p:nvSpPr>
         <p:spPr>
           <a:xfrm>
-            <a:off x="4206240" y="4517136"/>
-            <a:ext cx="3474720" cy="329184"/>
+            <a:off x="4206240" y="4745736"/>
+            <a:ext cx="3474720" cy="347472"/>
           </a:xfrm>
           <a:prstGeom prst="roundRect">
             <a:avLst>
-              <a:gd name="adj" fmla="val 16667"/>
+              <a:gd name="adj" fmla="val 15789"/>
             </a:avLst>
           </a:prstGeom>
           <a:solidFill>
@@ -9180,8 +9180,8 @@
         </p:nvSpPr>
         <p:spPr>
           <a:xfrm>
-            <a:off x="4343400" y="4517136"/>
-            <a:ext cx="3200400" cy="329184"/>
+            <a:off x="4343400" y="4745736"/>
+            <a:ext cx="3200400" cy="347472"/>
           </a:xfrm>
           <a:prstGeom prst="rect">
             <a:avLst/>
@@ -9219,12 +9219,12 @@
         </p:nvSpPr>
         <p:spPr>
           <a:xfrm>
-            <a:off x="4206240" y="4919472"/>
-            <a:ext cx="3474720" cy="329184"/>
+            <a:off x="4206240" y="5184648"/>
+            <a:ext cx="3474720" cy="347472"/>
           </a:xfrm>
           <a:prstGeom prst="roundRect">
             <a:avLst>
-              <a:gd name="adj" fmla="val 16667"/>
+              <a:gd name="adj" fmla="val 15789"/>
             </a:avLst>
           </a:prstGeom>
           <a:solidFill>
@@ -9246,8 +9246,8 @@
         </p:nvSpPr>
         <p:spPr>
           <a:xfrm>
-            <a:off x="4343400" y="4919472"/>
-            <a:ext cx="3200400" cy="329184"/>
+            <a:off x="4343400" y="5184648"/>
+            <a:ext cx="3200400" cy="347472"/>
           </a:xfrm>
           <a:prstGeom prst="rect">
             <a:avLst/>
@@ -9271,7 +9271,7 @@
                 <a:ea typeface="Calibri" pitchFamily="34" charset="-122"/>
                 <a:cs typeface="Calibri" pitchFamily="34" charset="-120"/>
               </a:rPr>
-              <a:t>MessageCreated</a:t>
+              <a:t>PaymentReceived</a:t>
             </a:r>
             <a:endParaRPr lang="en-US" sz="1150" dirty="0"/>
           </a:p>
@@ -9280,72 +9280,6 @@
       <p:sp>
         <p:nvSpPr>
           <p:cNvPr id="23" name="Shape 21"/>
-          <p:cNvSpPr/>
-          <p:nvPr/>
-        </p:nvSpPr>
-        <p:spPr>
-          <a:xfrm>
-            <a:off x="4206240" y="5321808"/>
-            <a:ext cx="3474720" cy="329184"/>
-          </a:xfrm>
-          <a:prstGeom prst="roundRect">
-            <a:avLst>
-              <a:gd name="adj" fmla="val 16667"/>
-            </a:avLst>
-          </a:prstGeom>
-          <a:solidFill>
-            <a:srgbClr val="FFFFFF"/>
-          </a:solidFill>
-          <a:ln w="12700">
-            <a:solidFill>
-              <a:srgbClr val="FFFFFF"/>
-            </a:solidFill>
-            <a:prstDash val="solid"/>
-          </a:ln>
-        </p:spPr>
-      </p:sp>
-      <p:sp>
-        <p:nvSpPr>
-          <p:cNvPr id="24" name="Text 22"/>
-          <p:cNvSpPr/>
-          <p:nvPr/>
-        </p:nvSpPr>
-        <p:spPr>
-          <a:xfrm>
-            <a:off x="4343400" y="5321808"/>
-            <a:ext cx="3200400" cy="329184"/>
-          </a:xfrm>
-          <a:prstGeom prst="rect">
-            <a:avLst/>
-          </a:prstGeom>
-          <a:noFill/>
-          <a:ln/>
-        </p:spPr>
-        <p:txBody>
-          <a:bodyPr wrap="square" lIns="0" tIns="0" rIns="0" bIns="0" rtlCol="0" anchor="ctr"/>
-          <a:lstStyle/>
-          <a:p>
-            <a:pPr indent="0" marL="0">
-              <a:buNone/>
-            </a:pPr>
-            <a:r>
-              <a:rPr lang="en-US" sz="1150" b="1" dirty="0">
-                <a:solidFill>
-                  <a:srgbClr val="2B2118"/>
-                </a:solidFill>
-                <a:latin typeface="Calibri" pitchFamily="34" charset="0"/>
-                <a:ea typeface="Calibri" pitchFamily="34" charset="-122"/>
-                <a:cs typeface="Calibri" pitchFamily="34" charset="-120"/>
-              </a:rPr>
-              <a:t>PaymentReceived</a:t>
-            </a:r>
-            <a:endParaRPr lang="en-US" sz="1150" dirty="0"/>
-          </a:p>
-        </p:txBody>
-      </p:sp>
-      <p:sp>
-        <p:nvSpPr>
-          <p:cNvPr id="25" name="Shape 23"/>
           <p:cNvSpPr/>
           <p:nvPr/>
         </p:nvSpPr>
@@ -9372,7 +9306,7 @@
       </p:sp>
       <p:sp>
         <p:nvSpPr>
-          <p:cNvPr id="26" name="Text 24"/>
+          <p:cNvPr id="24" name="Text 22"/>
           <p:cNvSpPr/>
           <p:nvPr/>
         </p:nvSpPr>
@@ -9411,7 +9345,7 @@
       </p:sp>
       <p:sp>
         <p:nvSpPr>
-          <p:cNvPr id="27" name="Text 25"/>
+          <p:cNvPr id="25" name="Text 23"/>
           <p:cNvSpPr/>
           <p:nvPr/>
         </p:nvSpPr>
@@ -9442,7 +9376,7 @@
                 <a:ea typeface="Calibri" pitchFamily="34" charset="-122"/>
                 <a:cs typeface="Calibri" pitchFamily="34" charset="-120"/>
               </a:rPr>
-              <a:t>17 tables · UUID keys</a:t>
+              <a:t>15 tables · UUID keys</a:t>
             </a:r>
             <a:endParaRPr lang="en-US" sz="1200" dirty="0"/>
           </a:p>
@@ -9467,7 +9401,7 @@
       </p:sp>
       <p:sp>
         <p:nvSpPr>
-          <p:cNvPr id="28" name="Shape 26"/>
+          <p:cNvPr id="26" name="Shape 24"/>
           <p:cNvSpPr/>
           <p:nvPr/>
         </p:nvSpPr>
@@ -9494,7 +9428,7 @@
       </p:sp>
       <p:sp>
         <p:nvSpPr>
-          <p:cNvPr id="29" name="Text 27"/>
+          <p:cNvPr id="27" name="Text 25"/>
           <p:cNvSpPr/>
           <p:nvPr/>
         </p:nvSpPr>
@@ -9533,14 +9467,14 @@
       </p:sp>
       <p:sp>
         <p:nvSpPr>
-          <p:cNvPr id="30" name="Text 28"/>
+          <p:cNvPr id="28" name="Text 26"/>
           <p:cNvSpPr/>
           <p:nvPr/>
         </p:nvSpPr>
         <p:spPr>
           <a:xfrm>
             <a:off x="8321040" y="3977640"/>
-            <a:ext cx="3017520" cy="1645920"/>
+            <a:ext cx="3017520" cy="1280160"/>
           </a:xfrm>
           <a:prstGeom prst="rect">
             <a:avLst/>
@@ -11004,7 +10938,7 @@
                 <a:ea typeface="Cambria" pitchFamily="34" charset="-122"/>
                 <a:cs typeface="Cambria" pitchFamily="34" charset="-120"/>
               </a:rPr>
-              <a:t>Direct messaging</a:t>
+              <a:t>Reviews you can trust</a:t>
             </a:r>
             <a:endParaRPr lang="en-US" sz="2100" dirty="0"/>
           </a:p>
@@ -11019,16 +10953,16 @@
         <p:spPr>
           <a:xfrm>
             <a:off x="960120" y="2423160"/>
-            <a:ext cx="4663440" cy="3108960"/>
-          </a:xfrm>
-          <a:prstGeom prst="rect">
-            <a:avLst/>
-          </a:prstGeom>
-          <a:noFill/>
-          <a:ln/>
-        </p:spPr>
-        <p:txBody>
-          <a:bodyPr wrap="square" lIns="0" tIns="0" rIns="0" bIns="0" rtlCol="0" anchor="ctr"/>
+            <a:ext cx="4663440" cy="2377440"/>
+          </a:xfrm>
+          <a:prstGeom prst="rect">
+            <a:avLst/>
+          </a:prstGeom>
+          <a:noFill/>
+          <a:ln/>
+        </p:spPr>
+        <p:txBody>
+          <a:bodyPr wrap="square" lIns="0" tIns="0" rIns="0" bIns="0" rtlCol="0" anchor="t"/>
           <a:lstStyle/>
           <a:p>
             <a:pPr marL="342900" indent="-342900">
@@ -11047,7 +10981,7 @@
                 <a:ea typeface="Calibri" pitchFamily="34" charset="-122"/>
                 <a:cs typeface="Calibri" pitchFamily="34" charset="-120"/>
               </a:rPr>
-              <a:t>One thread per customer–shop pair, enforced by a unique constraint — messaging twice reopens the same conversation</a:t>
+              <a:t>A review must attach to a real booking, and each booking can be reviewed exactly once</a:t>
             </a:r>
             <a:endParaRPr lang="en-US" sz="1250" dirty="0"/>
           </a:p>
@@ -11068,7 +11002,7 @@
                 <a:ea typeface="Calibri" pitchFamily="34" charset="-122"/>
                 <a:cs typeface="Calibri" pitchFamily="34" charset="-120"/>
               </a:rPr>
-              <a:t>Membership checked on every call; knowing a conversation ID is not authorisation</a:t>
+              <a:t>The booking must be COMPLETED — the appointment time has to have passed first</a:t>
             </a:r>
             <a:endParaRPr lang="en-US" sz="1250" dirty="0"/>
           </a:p>
@@ -11089,7 +11023,7 @@
                 <a:ea typeface="Calibri" pitchFamily="34" charset="-122"/>
                 <a:cs typeface="Calibri" pitchFamily="34" charset="-120"/>
               </a:rPr>
-              <a:t>Unread counts kept per side, so each party sees their own badge</a:t>
+              <a:t>Ratings recalculate the shop's average on write, so the figure is never stale</a:t>
             </a:r>
             <a:endParaRPr lang="en-US" sz="1250" dirty="0"/>
           </a:p>
@@ -11110,7 +11044,7 @@
                 <a:ea typeface="Calibri" pitchFamily="34" charset="-122"/>
                 <a:cs typeface="Calibri" pitchFamily="34" charset="-120"/>
               </a:rPr>
-              <a:t>Delivered live over WebSocket, and by push to anyone who isn't looking</a:t>
+              <a:t>Owners reply publicly; the reply is part of the record, not a private message</a:t>
             </a:r>
             <a:endParaRPr lang="en-US" sz="1250" dirty="0"/>
           </a:p>
@@ -11118,7 +11052,46 @@
       </p:sp>
       <p:sp>
         <p:nvSpPr>
-          <p:cNvPr id="7" name="Shape 5"/>
+          <p:cNvPr id="7" name="Text 5"/>
+          <p:cNvSpPr/>
+          <p:nvPr/>
+        </p:nvSpPr>
+        <p:spPr>
+          <a:xfrm>
+            <a:off x="960120" y="4892040"/>
+            <a:ext cx="4663440" cy="731520"/>
+          </a:xfrm>
+          <a:prstGeom prst="rect">
+            <a:avLst/>
+          </a:prstGeom>
+          <a:noFill/>
+          <a:ln/>
+        </p:spPr>
+        <p:txBody>
+          <a:bodyPr wrap="square" lIns="0" tIns="0" rIns="0" bIns="0" rtlCol="0" anchor="t"/>
+          <a:lstStyle/>
+          <a:p>
+            <a:pPr indent="0" marL="0">
+              <a:buNone/>
+            </a:pPr>
+            <a:r>
+              <a:rPr lang="en-US" sz="1100" i="1" dirty="0">
+                <a:solidFill>
+                  <a:srgbClr val="C9A227"/>
+                </a:solidFill>
+                <a:latin typeface="Calibri" pitchFamily="34" charset="0"/>
+                <a:ea typeface="Calibri" pitchFamily="34" charset="-122"/>
+                <a:cs typeface="Calibri" pitchFamily="34" charset="-120"/>
+              </a:rPr>
+              <a:t>Honest limit: completion is inferred from the clock, not from a check-in. A real attendance step is the correct fix and is roadmap, not built.</a:t>
+            </a:r>
+            <a:endParaRPr lang="en-US" sz="1100" dirty="0"/>
+          </a:p>
+        </p:txBody>
+      </p:sp>
+      <p:sp>
+        <p:nvSpPr>
+          <p:cNvPr id="8" name="Shape 6"/>
           <p:cNvSpPr/>
           <p:nvPr/>
         </p:nvSpPr>
@@ -11145,7 +11118,7 @@
       </p:sp>
       <p:sp>
         <p:nvSpPr>
-          <p:cNvPr id="8" name="Text 6"/>
+          <p:cNvPr id="9" name="Text 7"/>
           <p:cNvSpPr/>
           <p:nvPr/>
         </p:nvSpPr>
@@ -11184,7 +11157,7 @@
       </p:sp>
       <p:sp>
         <p:nvSpPr>
-          <p:cNvPr id="9" name="Text 7"/>
+          <p:cNvPr id="10" name="Text 8"/>
           <p:cNvSpPr/>
           <p:nvPr/>
         </p:nvSpPr>
@@ -11223,7 +11196,7 @@
       </p:sp>
       <p:sp>
         <p:nvSpPr>
-          <p:cNvPr id="10" name="Text 8"/>
+          <p:cNvPr id="11" name="Text 9"/>
           <p:cNvSpPr/>
           <p:nvPr/>
         </p:nvSpPr>
@@ -11239,7 +11212,7 @@
           <a:ln/>
         </p:spPr>
         <p:txBody>
-          <a:bodyPr wrap="square" lIns="0" tIns="0" rIns="0" bIns="0" rtlCol="0" anchor="ctr"/>
+          <a:bodyPr wrap="square" lIns="0" tIns="0" rIns="0" bIns="0" rtlCol="0" anchor="t"/>
           <a:lstStyle/>
           <a:p>
             <a:pPr marL="342900" indent="-342900">
@@ -11424,7 +11397,7 @@
                 <a:ea typeface="Cambria" pitchFamily="34" charset="-122"/>
                 <a:cs typeface="Cambria" pitchFamily="34" charset="-120"/>
               </a:rPr>
-              <a:t>Six features, one delivery pipeline</a:t>
+              <a:t>Five events, one delivery pipeline</a:t>
             </a:r>
             <a:endParaRPr lang="en-US" sz="3400" dirty="0"/>
           </a:p>
@@ -11439,7 +11412,7 @@
         <p:spPr>
           <a:xfrm>
             <a:off x="594360" y="1737360"/>
-            <a:ext cx="2651760" cy="3200400"/>
+            <a:ext cx="2651760" cy="3017520"/>
           </a:xfrm>
           <a:prstGeom prst="roundRect">
             <a:avLst>
@@ -11505,16 +11478,16 @@
         <p:spPr>
           <a:xfrm>
             <a:off x="822960" y="2286000"/>
-            <a:ext cx="2286000" cy="2468880"/>
-          </a:xfrm>
-          <a:prstGeom prst="rect">
-            <a:avLst/>
-          </a:prstGeom>
-          <a:noFill/>
-          <a:ln/>
-        </p:spPr>
-        <p:txBody>
-          <a:bodyPr wrap="square" lIns="0" tIns="0" rIns="0" bIns="0" rtlCol="0" anchor="ctr"/>
+            <a:ext cx="2286000" cy="2194560"/>
+          </a:xfrm>
+          <a:prstGeom prst="rect">
+            <a:avLst/>
+          </a:prstGeom>
+          <a:noFill/>
+          <a:ln/>
+        </p:spPr>
+        <p:txBody>
+          <a:bodyPr wrap="square" lIns="0" tIns="0" rIns="0" bIns="0" rtlCol="0" anchor="t"/>
           <a:lstStyle/>
           <a:p>
             <a:pPr marL="342900" indent="-342900">
@@ -11617,31 +11590,10 @@
                 <a:ea typeface="Calibri" pitchFamily="34" charset="-122"/>
                 <a:cs typeface="Calibri" pitchFamily="34" charset="-120"/>
               </a:rPr>
-              <a:t>Message sent</a:t>
+              <a:t>Payment received</a:t>
             </a:r>
             <a:endParaRPr lang="en-US" sz="1150" dirty="0"/>
           </a:p>
-          <a:p>
-            <a:pPr marL="342900" indent="-342900">
-              <a:spcAft>
-                <a:spcPts val="700"/>
-              </a:spcAft>
-              <a:buSzPct val="100000"/>
-              <a:buChar char="•"/>
-            </a:pPr>
-            <a:r>
-              <a:rPr lang="en-US" sz="1150" dirty="0">
-                <a:solidFill>
-                  <a:srgbClr val="2B2118"/>
-                </a:solidFill>
-                <a:latin typeface="Calibri" pitchFamily="34" charset="0"/>
-                <a:ea typeface="Calibri" pitchFamily="34" charset="-122"/>
-                <a:cs typeface="Calibri" pitchFamily="34" charset="-120"/>
-              </a:rPr>
-              <a:t>Payment received</a:t>
-            </a:r>
-            <a:endParaRPr lang="en-US" sz="1150" dirty="0"/>
-          </a:p>
         </p:txBody>
       </p:sp>
       <p:sp>
@@ -11652,7 +11604,7 @@
         </p:nvSpPr>
         <p:spPr>
           <a:xfrm>
-            <a:off x="3337560" y="3063240"/>
+            <a:off x="3337560" y="2926080"/>
             <a:ext cx="457200" cy="457200"/>
           </a:xfrm>
           <a:prstGeom prst="rect">
@@ -11692,11 +11644,11 @@
         <p:spPr>
           <a:xfrm>
             <a:off x="3840480" y="1737360"/>
-            <a:ext cx="3200400" cy="3200400"/>
+            <a:ext cx="3200400" cy="3017520"/>
           </a:xfrm>
           <a:prstGeom prst="roundRect">
             <a:avLst>
-              <a:gd name="adj" fmla="val 2857"/>
+              <a:gd name="adj" fmla="val 3030"/>
             </a:avLst>
           </a:prstGeom>
           <a:solidFill>
@@ -11796,17 +11748,17 @@
         </p:nvSpPr>
         <p:spPr>
           <a:xfrm>
-            <a:off x="4069080" y="3703320"/>
-            <a:ext cx="2743200" cy="1097280"/>
-          </a:xfrm>
-          <a:prstGeom prst="rect">
-            <a:avLst/>
-          </a:prstGeom>
-          <a:noFill/>
-          <a:ln/>
-        </p:spPr>
-        <p:txBody>
-          <a:bodyPr wrap="square" lIns="0" tIns="0" rIns="0" bIns="0" rtlCol="0" anchor="ctr"/>
+            <a:off x="4069080" y="3749040"/>
+            <a:ext cx="2743200" cy="914400"/>
+          </a:xfrm>
+          <a:prstGeom prst="rect">
+            <a:avLst/>
+          </a:prstGeom>
+          <a:noFill/>
+          <a:ln/>
+        </p:spPr>
+        <p:txBody>
+          <a:bodyPr wrap="square" lIns="0" tIns="0" rIns="0" bIns="0" rtlCol="0" anchor="t"/>
           <a:lstStyle/>
           <a:p>
             <a:pPr indent="0" marL="0">
@@ -11835,7 +11787,7 @@
         </p:nvSpPr>
         <p:spPr>
           <a:xfrm>
-            <a:off x="7086600" y="3063240"/>
+            <a:off x="7086600" y="2926080"/>
             <a:ext cx="457200" cy="457200"/>
           </a:xfrm>
           <a:prstGeom prst="rect">
@@ -11875,11 +11827,11 @@
         <p:spPr>
           <a:xfrm>
             <a:off x="7589520" y="1737360"/>
-            <a:ext cx="3977640" cy="960120"/>
+            <a:ext cx="3977640" cy="914400"/>
           </a:xfrm>
           <a:prstGeom prst="roundRect">
             <a:avLst>
-              <a:gd name="adj" fmla="val 9524"/>
+              <a:gd name="adj" fmla="val 10000"/>
             </a:avLst>
           </a:prstGeom>
           <a:solidFill>
@@ -11941,7 +11893,7 @@
         <p:spPr>
           <a:xfrm>
             <a:off x="7863840" y="2157984"/>
-            <a:ext cx="3474720" cy="457200"/>
+            <a:ext cx="3474720" cy="411480"/>
           </a:xfrm>
           <a:prstGeom prst="rect">
             <a:avLst/>
@@ -11979,12 +11931,12 @@
         </p:nvSpPr>
         <p:spPr>
           <a:xfrm>
-            <a:off x="7589520" y="2852928"/>
-            <a:ext cx="3977640" cy="960120"/>
+            <a:off x="7589520" y="2788920"/>
+            <a:ext cx="3977640" cy="914400"/>
           </a:xfrm>
           <a:prstGeom prst="roundRect">
             <a:avLst>
-              <a:gd name="adj" fmla="val 9524"/>
+              <a:gd name="adj" fmla="val 10000"/>
             </a:avLst>
           </a:prstGeom>
           <a:solidFill>
@@ -12006,7 +11958,7 @@
         </p:nvSpPr>
         <p:spPr>
           <a:xfrm>
-            <a:off x="7863840" y="2971800"/>
+            <a:off x="7863840" y="2907792"/>
             <a:ext cx="3474720" cy="274320"/>
           </a:xfrm>
           <a:prstGeom prst="rect">
@@ -12045,8 +11997,8 @@
         </p:nvSpPr>
         <p:spPr>
           <a:xfrm>
-            <a:off x="7863840" y="3273552"/>
-            <a:ext cx="3474720" cy="457200"/>
+            <a:off x="7863840" y="3209544"/>
+            <a:ext cx="3474720" cy="411480"/>
           </a:xfrm>
           <a:prstGeom prst="rect">
             <a:avLst/>
@@ -12084,12 +12036,12 @@
         </p:nvSpPr>
         <p:spPr>
           <a:xfrm>
-            <a:off x="7589520" y="3968496"/>
-            <a:ext cx="3977640" cy="960120"/>
+            <a:off x="7589520" y="3840480"/>
+            <a:ext cx="3977640" cy="914400"/>
           </a:xfrm>
           <a:prstGeom prst="roundRect">
             <a:avLst>
-              <a:gd name="adj" fmla="val 9524"/>
+              <a:gd name="adj" fmla="val 10000"/>
             </a:avLst>
           </a:prstGeom>
           <a:solidFill>
@@ -12111,7 +12063,7 @@
         </p:nvSpPr>
         <p:spPr>
           <a:xfrm>
-            <a:off x="7863840" y="4087368"/>
+            <a:off x="7863840" y="3959352"/>
             <a:ext cx="3474720" cy="274320"/>
           </a:xfrm>
           <a:prstGeom prst="rect">
@@ -12150,8 +12102,8 @@
         </p:nvSpPr>
         <p:spPr>
           <a:xfrm>
-            <a:off x="7863840" y="4389120"/>
-            <a:ext cx="3474720" cy="457200"/>
+            <a:off x="7863840" y="4261104"/>
+            <a:ext cx="3474720" cy="411480"/>
           </a:xfrm>
           <a:prstGeom prst="rect">
             <a:avLst/>
@@ -12189,7 +12141,7 @@
         </p:nvSpPr>
         <p:spPr>
           <a:xfrm>
-            <a:off x="594360" y="5120640"/>
+            <a:off x="594360" y="4983480"/>
             <a:ext cx="10972800" cy="822960"/>
           </a:xfrm>
           <a:prstGeom prst="roundRect">
@@ -12216,7 +12168,7 @@
         </p:nvSpPr>
         <p:spPr>
           <a:xfrm>
-            <a:off x="960120" y="5285232"/>
+            <a:off x="960120" y="5148072"/>
             <a:ext cx="10241280" cy="502920"/>
           </a:xfrm>
           <a:prstGeom prst="rect">

</xml_diff>